<commit_message>
Made changes to presentation
</commit_message>
<xml_diff>
--- a/presentation/Supply_Chain_Sentinel.pptx
+++ b/presentation/Supply_Chain_Sentinel.pptx
@@ -1364,7 +1364,7 @@
           <a:p>
             <a:fld id="{602F36A3-196C-2340-928B-2735ABFC683D}" type="datetime1">
               <a:rPr lang="de-CH" smtClean="0"/>
-              <a:t>19.06.26</a:t>
+              <a:t>22.06.26</a:t>
             </a:fld>
             <a:endParaRPr lang="en-US"/>
           </a:p>
@@ -1532,7 +1532,7 @@
           <a:p>
             <a:fld id="{34404B13-8432-E04B-92A7-4A1AD989D8E0}" type="datetime1">
               <a:rPr lang="de-CH" smtClean="0"/>
-              <a:t>19.06.26</a:t>
+              <a:t>22.06.26</a:t>
             </a:fld>
             <a:endParaRPr lang="en-US"/>
           </a:p>
@@ -1710,7 +1710,7 @@
           <a:p>
             <a:fld id="{1D68F4C9-768D-C344-A3EC-C9D296A69E2E}" type="datetime1">
               <a:rPr lang="de-CH" smtClean="0"/>
-              <a:t>19.06.26</a:t>
+              <a:t>22.06.26</a:t>
             </a:fld>
             <a:endParaRPr lang="en-US"/>
           </a:p>
@@ -1878,7 +1878,7 @@
           <a:p>
             <a:fld id="{1CD641EE-342D-484E-BC9F-442E04576153}" type="datetime1">
               <a:rPr lang="de-CH" smtClean="0"/>
-              <a:t>19.06.26</a:t>
+              <a:t>22.06.26</a:t>
             </a:fld>
             <a:endParaRPr lang="en-US"/>
           </a:p>
@@ -2123,7 +2123,7 @@
           <a:p>
             <a:fld id="{D2D0FF02-26D6-CB4B-B2D6-056F329435EE}" type="datetime1">
               <a:rPr lang="de-CH" smtClean="0"/>
-              <a:t>19.06.26</a:t>
+              <a:t>22.06.26</a:t>
             </a:fld>
             <a:endParaRPr lang="en-US"/>
           </a:p>
@@ -2408,7 +2408,7 @@
           <a:p>
             <a:fld id="{953A440E-2EAB-D84E-B57B-279937A87049}" type="datetime1">
               <a:rPr lang="de-CH" smtClean="0"/>
-              <a:t>19.06.26</a:t>
+              <a:t>22.06.26</a:t>
             </a:fld>
             <a:endParaRPr lang="en-US"/>
           </a:p>
@@ -2827,7 +2827,7 @@
           <a:p>
             <a:fld id="{BFC78A58-9B46-2042-BBA9-CB92C9D372CF}" type="datetime1">
               <a:rPr lang="de-CH" smtClean="0"/>
-              <a:t>19.06.26</a:t>
+              <a:t>22.06.26</a:t>
             </a:fld>
             <a:endParaRPr lang="en-US"/>
           </a:p>
@@ -2944,7 +2944,7 @@
           <a:p>
             <a:fld id="{35CFDC8E-CC62-DB47-BBDE-797882642D4C}" type="datetime1">
               <a:rPr lang="de-CH" smtClean="0"/>
-              <a:t>19.06.26</a:t>
+              <a:t>22.06.26</a:t>
             </a:fld>
             <a:endParaRPr lang="en-US"/>
           </a:p>
@@ -3039,7 +3039,7 @@
           <a:p>
             <a:fld id="{62F475DB-65E3-AB46-8CD4-47304E43D415}" type="datetime1">
               <a:rPr lang="de-CH" smtClean="0"/>
-              <a:t>19.06.26</a:t>
+              <a:t>22.06.26</a:t>
             </a:fld>
             <a:endParaRPr lang="en-US"/>
           </a:p>
@@ -3314,7 +3314,7 @@
           <a:p>
             <a:fld id="{7020F6DA-24F4-2D46-BB3D-4D7322336F46}" type="datetime1">
               <a:rPr lang="de-CH" smtClean="0"/>
-              <a:t>19.06.26</a:t>
+              <a:t>22.06.26</a:t>
             </a:fld>
             <a:endParaRPr lang="en-US"/>
           </a:p>
@@ -3566,7 +3566,7 @@
           <a:p>
             <a:fld id="{2EBDAD4E-8873-4440-8E24-CB8AEDF8880E}" type="datetime1">
               <a:rPr lang="de-CH" smtClean="0"/>
-              <a:t>19.06.26</a:t>
+              <a:t>22.06.26</a:t>
             </a:fld>
             <a:endParaRPr lang="en-US"/>
           </a:p>
@@ -3777,7 +3777,7 @@
           <a:p>
             <a:fld id="{8BB81234-AE5F-CA4B-9222-81AC638D9DC4}" type="datetime1">
               <a:rPr lang="de-CH" smtClean="0"/>
-              <a:t>19.06.26</a:t>
+              <a:t>22.06.26</a:t>
             </a:fld>
             <a:endParaRPr lang="en-US"/>
           </a:p>
@@ -4434,7 +4434,43 @@
                 </a:solidFill>
                 <a:latin typeface="Calibri"/>
               </a:rPr>
-              <a:t>Lorenz Rösgen, Dan Tigu</a:t>
+              <a:t>Lorenz Rösgen, Dan </a:t>
+            </a:r>
+            <a:r>
+              <a:rPr lang="de-CH" sz="1400" b="0" dirty="0" err="1">
+                <a:solidFill>
+                  <a:srgbClr val="BBC6E0"/>
+                </a:solidFill>
+                <a:latin typeface="Calibri"/>
+              </a:rPr>
+              <a:t>Tigu</a:t>
+            </a:r>
+            <a:r>
+              <a:rPr lang="de-CH" sz="1400" b="0" dirty="0">
+                <a:solidFill>
+                  <a:srgbClr val="BBC6E0"/>
+                </a:solidFill>
+                <a:latin typeface="Calibri"/>
+              </a:rPr>
+              <a:t>, Marti </a:t>
+            </a:r>
+            <a:r>
+              <a:rPr lang="de-CH" sz="1400" b="0" dirty="0" err="1">
+                <a:solidFill>
+                  <a:srgbClr val="BBC6E0"/>
+                </a:solidFill>
+                <a:latin typeface="Calibri"/>
+              </a:rPr>
+              <a:t>Solà</a:t>
+            </a:r>
+            <a:r>
+              <a:rPr lang="de-CH" sz="1400" b="0" dirty="0">
+                <a:solidFill>
+                  <a:srgbClr val="BBC6E0"/>
+                </a:solidFill>
+                <a:latin typeface="Calibri"/>
+              </a:rPr>
+              <a:t> Puig </a:t>
             </a:r>
             <a:endParaRPr sz="1400" b="0" dirty="0">
               <a:solidFill>

</xml_diff>